<commit_message>
Add PII anonymization caveat to Support IT webinar deck
The current n8n workflow sends the ticket's user name and description
to GPT-4o unmasked (verified against 150_n8n_Support_IT_Intelligent_REEL_Corrige).
Slide 6 now flags this as a known limitation until the workflow gets
the same sanitize/desanitize pattern already used by the RAG workflow.

Co-Authored-By: Claude Sonnet 5 <noreply@anthropic.com>
</commit_message>
<xml_diff>
--- a/docs/transferai-admin/Webinaire_Support_IT_Intelligent_GOUHO_Bi_Neantien_Jean_Baptiste.pptx
+++ b/docs/transferai-admin/Webinaire_Support_IT_Intelligent_GOUHO_Bi_Neantien_Jean_Baptiste.pptx
@@ -5451,6 +5451,72 @@
       </p:sp>
       <p:sp>
         <p:nvSpPr>
+          <p:cNvPr id="90" name="Shape"/>
+          <p:cNvSpPr/>
+          <p:nvPr/>
+        </p:nvSpPr>
+        <p:spPr>
+          <a:xfrm>
+            <a:off x="548640" y="5885000"/>
+            <a:ext cx="10881360" cy="460000"/>
+          </a:xfrm>
+          <a:prstGeom prst="roundRect">
+            <a:avLst>
+              <a:gd name="adj" fmla="val 8000"/>
+            </a:avLst>
+          </a:prstGeom>
+          <a:solidFill>
+            <a:srgbClr val="17324D"/>
+          </a:solidFill>
+          <a:ln w="9525">
+            <a:solidFill>
+              <a:srgbClr val="E8A020"/>
+            </a:solidFill>
+            <a:prstDash val="solid"/>
+          </a:ln>
+        </p:spPr>
+      </p:sp>
+      <p:sp>
+        <p:nvSpPr>
+          <p:cNvPr id="91" name="Text"/>
+          <p:cNvSpPr/>
+          <p:nvPr/>
+        </p:nvSpPr>
+        <p:spPr>
+          <a:xfrm>
+            <a:off x="822960" y="5885000"/>
+            <a:ext cx="10332720" cy="460000"/>
+          </a:xfrm>
+          <a:prstGeom prst="rect">
+            <a:avLst/>
+          </a:prstGeom>
+          <a:noFill/>
+          <a:ln/>
+        </p:spPr>
+        <p:txBody>
+          <a:bodyPr wrap="square" rtlCol="0" anchor="ctr"/>
+          <a:lstStyle/>
+          <a:p>
+            <a:pPr indent="0" marL="0">
+              <a:buNone/>
+            </a:pPr>
+            <a:r>
+              <a:rPr lang="en-US" sz="950" b="1" dirty="0">
+                <a:solidFill>
+                  <a:srgbClr val="E8A020"/>
+                </a:solidFill>
+                <a:latin typeface="Calibri" pitchFamily="34" charset="0"/>
+                <a:ea typeface="Calibri" pitchFamily="34" charset="-122"/>
+                <a:cs typeface="Calibri" pitchFamily="34" charset="-120"/>
+              </a:rPr>
+              <a:t>⚠ Limite actuelle : nom et description du ticket envoyés à l'IA sans anonymisation — ajout prévu avant tout déploiement en production (même principe que le RAG documentaire).</a:t>
+            </a:r>
+            <a:endParaRPr lang="en-US" sz="950" dirty="0"/>
+          </a:p>
+        </p:txBody>
+      </p:sp>
+      <p:sp>
+        <p:nvSpPr>
           <p:cNvPr id="19" name="Text"/>
           <p:cNvSpPr/>
           <p:nvPr/>

</xml_diff>

<commit_message>
Confirm PII anonymization fix on Support IT deck, add workflow export
Slide 6's warning banner now confirms anonymization is live instead of
flagging it as a gap (matches the n8n workflow patched and tested
today, executions #13621/#13625). Also adds a versioned export of the
patched workflow (162_...) alongside the original 150_... for reference.

Co-Authored-By: Claude Sonnet 5 <noreply@anthropic.com>
</commit_message>
<xml_diff>
--- a/docs/transferai-admin/Webinaire_Support_IT_Intelligent_GOUHO_Bi_Neantien_Jean_Baptiste.pptx
+++ b/docs/transferai-admin/Webinaire_Support_IT_Intelligent_GOUHO_Bi_Neantien_Jean_Baptiste.pptx
@@ -5470,7 +5470,7 @@
           </a:solidFill>
           <a:ln w="9525">
             <a:solidFill>
-              <a:srgbClr val="E8A020"/>
+              <a:srgbClr val="0D7D6B"/>
             </a:solidFill>
             <a:prstDash val="solid"/>
           </a:ln>
@@ -5503,13 +5503,13 @@
             <a:r>
               <a:rPr lang="en-US" sz="950" b="1" dirty="0">
                 <a:solidFill>
-                  <a:srgbClr val="E8A020"/>
-                </a:solidFill>
-                <a:latin typeface="Calibri" pitchFamily="34" charset="0"/>
-                <a:ea typeface="Calibri" pitchFamily="34" charset="-122"/>
-                <a:cs typeface="Calibri" pitchFamily="34" charset="-120"/>
-              </a:rPr>
-              <a:t>⚠ Limite actuelle : nom et description du ticket envoyés à l'IA sans anonymisation — ajout prévu avant tout déploiement en production (même principe que le RAG documentaire).</a:t>
+                  <a:srgbClr val="3FC1D0"/>
+                </a:solidFill>
+                <a:latin typeface="Calibri" pitchFamily="34" charset="0"/>
+                <a:ea typeface="Calibri" pitchFamily="34" charset="-122"/>
+                <a:cs typeface="Calibri" pitchFamily="34" charset="-120"/>
+              </a:rPr>
+              <a:t>✓ Anonymisation active : le nom du demandeur n'est jamais transmis à l'IA, et les données sensibles du texte libre sont tokenisées avant l'analyse GPT-4o (même principe que le RAG documentaire).</a:t>
             </a:r>
             <a:endParaRPr lang="en-US" sz="950" dirty="0"/>
           </a:p>

</xml_diff>